<commit_message>
Add complete model architecture slide; retime speaking script
Co-Authored-By: Claude Sonnet 5.5 <noreply@anthropic.com>
Claude-Session: https://claude.ai/code/session_01Mrmk7xtGXEASaZHBUGuSEF
</commit_message>
<xml_diff>
--- a/DR_Thesis_5min.pptx
+++ b/DR_Thesis_5min.pptx
@@ -16,6 +16,7 @@
     <p:sldId id="259" r:id="rId5"/>
     <p:sldId id="292" r:id="rId18"/>
     <p:sldId id="288" r:id="rId7"/>
+    <p:sldId id="293" r:id="rId19"/>
     <p:sldId id="291" r:id="rId8"/>
     <p:sldId id="264" r:id="rId9"/>
     <p:sldId id="265" r:id="rId10"/>
@@ -21735,6 +21736,1294 @@
 </p:sld>
 </file>
 
+<file path=ppt/slides/slide12.xml><?xml version="1.0" encoding="utf-8"?>
+<p:sld xmlns:a="http://schemas.openxmlformats.org/drawingml/2006/main" xmlns:r="http://schemas.openxmlformats.org/officeDocument/2006/relationships" xmlns:p="http://schemas.openxmlformats.org/presentationml/2006/main">
+  <p:cSld>
+    <p:spTree>
+      <p:nvGrpSpPr>
+        <p:cNvPr id="1" name=""/>
+        <p:cNvGrpSpPr/>
+        <p:nvPr/>
+      </p:nvGrpSpPr>
+      <p:grpSpPr>
+        <a:xfrm>
+          <a:off x="0" y="0"/>
+          <a:ext cx="0" cy="0"/>
+          <a:chOff x="0" y="0"/>
+          <a:chExt cx="0" cy="0"/>
+        </a:xfrm>
+      </p:grpSpPr>
+      <p:sp>
+        <p:nvSpPr>
+          <p:cNvPr id="2" name="Title 1"/>
+          <p:cNvSpPr>
+            <a:spLocks noGrp="1"/>
+          </p:cNvSpPr>
+          <p:nvPr>
+            <p:ph type="title"/>
+          </p:nvPr>
+        </p:nvSpPr>
+        <p:spPr>
+          <a:xfrm>
+            <a:off x="713232" y="283464"/>
+            <a:ext cx="7909560" cy="502920"/>
+          </a:xfrm>
+        </p:spPr>
+        <p:txBody>
+          <a:bodyPr/>
+          <a:lstStyle/>
+          <a:p>
+            <a:pPr algn="l"/>
+            <a:r>
+              <a:rPr sz="2200" b="1">
+                <a:solidFill>
+                  <a:srgbClr val="121212"/>
+                </a:solidFill>
+                <a:latin typeface="Arial"/>
+              </a:rPr>
+              <a:t>Complete Model Architecture</a:t>
+            </a:r>
+          </a:p>
+        </p:txBody>
+      </p:sp>
+      <p:sp>
+        <p:nvSpPr>
+          <p:cNvPr id="3" name="TextBox 2"/>
+          <p:cNvSpPr txBox="1"/>
+          <p:nvPr/>
+        </p:nvSpPr>
+        <p:spPr>
+          <a:xfrm>
+            <a:off x="566928" y="932688"/>
+            <a:ext cx="5486400" cy="256032"/>
+          </a:xfrm>
+          <a:prstGeom prst="rect">
+            <a:avLst/>
+          </a:prstGeom>
+          <a:noFill/>
+        </p:spPr>
+        <p:txBody>
+          <a:bodyPr wrap="square" lIns="27432" tIns="18288" rIns="27432" bIns="18288" anchor="t">
+            <a:spAutoFit/>
+          </a:bodyPr>
+          <a:lstStyle/>
+          <a:p>
+            <a:pPr algn="l"/>
+            <a:r>
+              <a:rPr sz="1480" b="1" i="0">
+                <a:solidFill>
+                  <a:srgbClr val="121212"/>
+                </a:solidFill>
+                <a:latin typeface="Arial"/>
+              </a:rPr>
+              <a:t>From fundus image to a calibrated early-DR flag</a:t>
+            </a:r>
+          </a:p>
+        </p:txBody>
+      </p:sp>
+      <p:sp>
+        <p:nvSpPr>
+          <p:cNvPr id="25" name="TextBox 24">
+            <a:extLst>
+              <a:ext uri="{FF2B5EF4-FFF2-40B4-BE49-F238E27FC236}">
+                <a16:creationId xmlns:a16="http://schemas.microsoft.com/office/drawing/2014/main" id="{6AB72007-F5D0-AF78-B89C-794457398D1F}"/>
+              </a:ext>
+            </a:extLst>
+          </p:cNvPr>
+          <p:cNvSpPr txBox="1"/>
+          <p:nvPr/>
+        </p:nvSpPr>
+        <p:spPr>
+          <a:xfrm>
+            <a:off x="8801100" y="4792436"/>
+            <a:ext cx="342900" cy="261610"/>
+          </a:xfrm>
+          <a:prstGeom prst="rect">
+            <a:avLst/>
+          </a:prstGeom>
+          <a:noFill/>
+        </p:spPr>
+        <p:txBody>
+          <a:bodyPr wrap="square" rtlCol="0">
+            <a:spAutoFit/>
+          </a:bodyPr>
+          <a:lstStyle/>
+          <a:p>
+            <a:r>
+              <a:rPr lang="en-US" sz="1100" dirty="0"/>
+              <a:t>6</a:t>
+            </a:r>
+          </a:p>
+        </p:txBody>
+      </p:sp>
+      <p:sp>
+        <p:nvSpPr>
+          <p:cNvPr id="101" name="Label train"/>
+          <p:cNvSpPr txBox="1"/>
+          <p:nvPr/>
+        </p:nvSpPr>
+        <p:spPr>
+          <a:xfrm>
+            <a:off x="502920" y="1188720"/>
+            <a:ext cx="5486400" cy="201168"/>
+          </a:xfrm>
+          <a:prstGeom prst="rect">
+            <a:avLst/>
+          </a:prstGeom>
+          <a:noFill/>
+        </p:spPr>
+        <p:txBody>
+          <a:bodyPr wrap="square" lIns="27432" tIns="18288" rIns="27432" bIns="18288" anchor="t">
+            <a:spAutoFit/>
+          </a:bodyPr>
+          <a:lstStyle/>
+          <a:p>
+            <a:pPr algn="l"/>
+            <a:r>
+              <a:rPr sz="950" b="1">
+                <a:solidFill>
+                  <a:srgbClr val="1E7A5A"/>
+                </a:solidFill>
+                <a:latin typeface="Arial"/>
+              </a:rPr>
+              <a:t>TRAIN: one model per arm, task and seed</a:t>
+            </a:r>
+          </a:p>
+        </p:txBody>
+      </p:sp>
+      <p:sp>
+        <p:nvSpPr>
+          <p:cNvPr id="102" name="Train 1"/>
+          <p:cNvSpPr/>
+          <p:nvPr/>
+        </p:nvSpPr>
+        <p:spPr>
+          <a:xfrm>
+            <a:off x="502920" y="1481328"/>
+            <a:ext cx="1216152" cy="914400"/>
+          </a:xfrm>
+          <a:prstGeom prst="roundRect">
+            <a:avLst/>
+          </a:prstGeom>
+          <a:solidFill>
+            <a:srgbClr val="BCCFE4"/>
+          </a:solidFill>
+          <a:ln w="9525">
+            <a:solidFill>
+              <a:srgbClr val="BCCFE4"/>
+            </a:solidFill>
+          </a:ln>
+        </p:spPr>
+        <p:style>
+          <a:lnRef idx="1">
+            <a:schemeClr val="accent1"/>
+          </a:lnRef>
+          <a:fillRef idx="3">
+            <a:schemeClr val="accent1"/>
+          </a:fillRef>
+          <a:effectRef idx="2">
+            <a:schemeClr val="accent1"/>
+          </a:effectRef>
+          <a:fontRef idx="minor">
+            <a:schemeClr val="lt1"/>
+          </a:fontRef>
+        </p:style>
+        <p:txBody>
+          <a:bodyPr wrap="square" lIns="54864" tIns="36576" rIns="54864" bIns="36576" rtlCol="0" anchor="ctr"/>
+          <a:lstStyle/>
+          <a:p>
+            <a:pPr algn="ctr"/>
+            <a:r>
+              <a:rPr sz="1000" b="1">
+                <a:solidFill>
+                  <a:srgbClr val="121212"/>
+                </a:solidFill>
+                <a:latin typeface="Arial"/>
+              </a:rPr>
+              <a:t>Fundus image</a:t>
+            </a:r>
+          </a:p>
+          <a:p>
+            <a:pPr algn="ctr"/>
+            <a:r>
+              <a:rPr sz="800" b="0">
+                <a:solidFill>
+                  <a:srgbClr val="2B2B2B"/>
+                </a:solidFill>
+                <a:latin typeface="Arial"/>
+              </a:rPr>
+              <a:t>DDR, EyePACS, APTOS; frozen patient-level splits</a:t>
+            </a:r>
+          </a:p>
+        </p:txBody>
+      </p:sp>
+      <p:sp>
+        <p:nvSpPr>
+          <p:cNvPr id="103" name="Arrow 1"/>
+          <p:cNvSpPr/>
+          <p:nvPr/>
+        </p:nvSpPr>
+        <p:spPr>
+          <a:xfrm>
+            <a:off x="1746504" y="1938528"/>
+            <a:ext cx="128016" cy="0"/>
+          </a:xfrm>
+          <a:prstGeom prst="line">
+            <a:avLst/>
+          </a:prstGeom>
+          <a:noFill/>
+          <a:ln w="25400">
+            <a:solidFill>
+              <a:srgbClr val="555555"/>
+            </a:solidFill>
+            <a:prstDash val="solid"/>
+            <a:tailEnd type="triangle"/>
+          </a:ln>
+        </p:spPr>
+        <p:txBody>
+          <a:bodyPr/>
+          <a:lstStyle/>
+          <a:p>
+            <a:endParaRPr sz="1050"/>
+          </a:p>
+        </p:txBody>
+      </p:sp>
+      <p:sp>
+        <p:nvSpPr>
+          <p:cNvPr id="104" name="Train 2"/>
+          <p:cNvSpPr/>
+          <p:nvPr/>
+        </p:nvSpPr>
+        <p:spPr>
+          <a:xfrm>
+            <a:off x="1901952" y="1481328"/>
+            <a:ext cx="1216152" cy="914400"/>
+          </a:xfrm>
+          <a:prstGeom prst="roundRect">
+            <a:avLst/>
+          </a:prstGeom>
+          <a:solidFill>
+            <a:srgbClr val="BCCFE4"/>
+          </a:solidFill>
+          <a:ln w="9525">
+            <a:solidFill>
+              <a:srgbClr val="BCCFE4"/>
+            </a:solidFill>
+          </a:ln>
+        </p:spPr>
+        <p:style>
+          <a:lnRef idx="1">
+            <a:schemeClr val="accent1"/>
+          </a:lnRef>
+          <a:fillRef idx="3">
+            <a:schemeClr val="accent1"/>
+          </a:fillRef>
+          <a:effectRef idx="2">
+            <a:schemeClr val="accent1"/>
+          </a:effectRef>
+          <a:fontRef idx="minor">
+            <a:schemeClr val="lt1"/>
+          </a:fontRef>
+        </p:style>
+        <p:txBody>
+          <a:bodyPr wrap="square" lIns="54864" tIns="36576" rIns="54864" bIns="36576" rtlCol="0" anchor="ctr"/>
+          <a:lstStyle/>
+          <a:p>
+            <a:pPr algn="ctr"/>
+            <a:r>
+              <a:rPr sz="1000" b="1">
+                <a:solidFill>
+                  <a:srgbClr val="121212"/>
+                </a:solidFill>
+                <a:latin typeface="Arial"/>
+              </a:rPr>
+              <a:t>Preprocess</a:t>
+            </a:r>
+          </a:p>
+          <a:p>
+            <a:pPr algn="ctr"/>
+            <a:r>
+              <a:rPr sz="800" b="0">
+                <a:solidFill>
+                  <a:srgbClr val="2B2B2B"/>
+                </a:solidFill>
+                <a:latin typeface="Arial"/>
+              </a:rPr>
+              <a:t>Crop border, pad to square, resize to 512 px (colour norm optional)</a:t>
+            </a:r>
+          </a:p>
+        </p:txBody>
+      </p:sp>
+      <p:sp>
+        <p:nvSpPr>
+          <p:cNvPr id="105" name="Arrow 2"/>
+          <p:cNvSpPr/>
+          <p:nvPr/>
+        </p:nvSpPr>
+        <p:spPr>
+          <a:xfrm>
+            <a:off x="3145536" y="1938528"/>
+            <a:ext cx="128016" cy="0"/>
+          </a:xfrm>
+          <a:prstGeom prst="line">
+            <a:avLst/>
+          </a:prstGeom>
+          <a:noFill/>
+          <a:ln w="25400">
+            <a:solidFill>
+              <a:srgbClr val="555555"/>
+            </a:solidFill>
+            <a:prstDash val="solid"/>
+            <a:tailEnd type="triangle"/>
+          </a:ln>
+        </p:spPr>
+        <p:txBody>
+          <a:bodyPr/>
+          <a:lstStyle/>
+          <a:p>
+            <a:endParaRPr sz="1050"/>
+          </a:p>
+        </p:txBody>
+      </p:sp>
+      <p:sp>
+        <p:nvSpPr>
+          <p:cNvPr id="106" name="Train 3"/>
+          <p:cNvSpPr/>
+          <p:nvPr/>
+        </p:nvSpPr>
+        <p:spPr>
+          <a:xfrm>
+            <a:off x="3300984" y="1481328"/>
+            <a:ext cx="1216152" cy="914400"/>
+          </a:xfrm>
+          <a:prstGeom prst="roundRect">
+            <a:avLst/>
+          </a:prstGeom>
+          <a:solidFill>
+            <a:srgbClr val="FFFFFF"/>
+          </a:solidFill>
+          <a:ln w="9525">
+            <a:solidFill>
+              <a:srgbClr val="CDD2D7"/>
+            </a:solidFill>
+          </a:ln>
+        </p:spPr>
+        <p:style>
+          <a:lnRef idx="1">
+            <a:schemeClr val="accent1"/>
+          </a:lnRef>
+          <a:fillRef idx="3">
+            <a:schemeClr val="accent1"/>
+          </a:fillRef>
+          <a:effectRef idx="2">
+            <a:schemeClr val="accent1"/>
+          </a:effectRef>
+          <a:fontRef idx="minor">
+            <a:schemeClr val="lt1"/>
+          </a:fontRef>
+        </p:style>
+        <p:txBody>
+          <a:bodyPr wrap="square" lIns="54864" tIns="36576" rIns="54864" bIns="36576" rtlCol="0" anchor="ctr"/>
+          <a:lstStyle/>
+          <a:p>
+            <a:pPr algn="ctr"/>
+            <a:r>
+              <a:rPr sz="1000" b="1">
+                <a:solidFill>
+                  <a:srgbClr val="121212"/>
+                </a:solidFill>
+                <a:latin typeface="Arial"/>
+              </a:rPr>
+              <a:t>Sampler + augment</a:t>
+            </a:r>
+          </a:p>
+          <a:p>
+            <a:pPr algn="ctr"/>
+            <a:r>
+              <a:rPr sz="800" b="0">
+                <a:solidFill>
+                  <a:srgbClr val="2B2B2B"/>
+                </a:solidFill>
+                <a:latin typeface="Arial"/>
+              </a:rPr>
+              <a:t>Arm B: source-balanced. Weighted, class-aware or repeat-factor. Mild or strong</a:t>
+            </a:r>
+          </a:p>
+        </p:txBody>
+      </p:sp>
+      <p:sp>
+        <p:nvSpPr>
+          <p:cNvPr id="107" name="Arrow 3"/>
+          <p:cNvSpPr/>
+          <p:nvPr/>
+        </p:nvSpPr>
+        <p:spPr>
+          <a:xfrm>
+            <a:off x="4544568" y="1938528"/>
+            <a:ext cx="128016" cy="0"/>
+          </a:xfrm>
+          <a:prstGeom prst="line">
+            <a:avLst/>
+          </a:prstGeom>
+          <a:noFill/>
+          <a:ln w="25400">
+            <a:solidFill>
+              <a:srgbClr val="555555"/>
+            </a:solidFill>
+            <a:prstDash val="solid"/>
+            <a:tailEnd type="triangle"/>
+          </a:ln>
+        </p:spPr>
+        <p:txBody>
+          <a:bodyPr/>
+          <a:lstStyle/>
+          <a:p>
+            <a:endParaRPr sz="1050"/>
+          </a:p>
+        </p:txBody>
+      </p:sp>
+      <p:sp>
+        <p:nvSpPr>
+          <p:cNvPr id="108" name="Train 4"/>
+          <p:cNvSpPr/>
+          <p:nvPr/>
+        </p:nvSpPr>
+        <p:spPr>
+          <a:xfrm>
+            <a:off x="4700016" y="1481328"/>
+            <a:ext cx="1216152" cy="914400"/>
+          </a:xfrm>
+          <a:prstGeom prst="roundRect">
+            <a:avLst/>
+          </a:prstGeom>
+          <a:solidFill>
+            <a:srgbClr val="E3F2EA"/>
+          </a:solidFill>
+          <a:ln w="9525">
+            <a:solidFill>
+              <a:srgbClr val="1E7A5A"/>
+            </a:solidFill>
+          </a:ln>
+        </p:spPr>
+        <p:style>
+          <a:lnRef idx="1">
+            <a:schemeClr val="accent1"/>
+          </a:lnRef>
+          <a:fillRef idx="3">
+            <a:schemeClr val="accent1"/>
+          </a:fillRef>
+          <a:effectRef idx="2">
+            <a:schemeClr val="accent1"/>
+          </a:effectRef>
+          <a:fontRef idx="minor">
+            <a:schemeClr val="lt1"/>
+          </a:fontRef>
+        </p:style>
+        <p:txBody>
+          <a:bodyPr wrap="square" lIns="54864" tIns="36576" rIns="54864" bIns="36576" rtlCol="0" anchor="ctr"/>
+          <a:lstStyle/>
+          <a:p>
+            <a:pPr algn="ctr"/>
+            <a:r>
+              <a:rPr sz="1000" b="1">
+                <a:solidFill>
+                  <a:srgbClr val="121212"/>
+                </a:solidFill>
+                <a:latin typeface="Arial"/>
+              </a:rPr>
+              <a:t>Backbone</a:t>
+            </a:r>
+          </a:p>
+          <a:p>
+            <a:pPr algn="ctr"/>
+            <a:r>
+              <a:rPr sz="800" b="0">
+                <a:solidFill>
+                  <a:srgbClr val="2B2B2B"/>
+                </a:solidFill>
+                <a:latin typeface="Arial"/>
+              </a:rPr>
+              <a:t>EfficientNet-B0, ImageNet weights (ViT + RETFound as extension)</a:t>
+            </a:r>
+          </a:p>
+        </p:txBody>
+      </p:sp>
+      <p:sp>
+        <p:nvSpPr>
+          <p:cNvPr id="109" name="Arrow 4"/>
+          <p:cNvSpPr/>
+          <p:nvPr/>
+        </p:nvSpPr>
+        <p:spPr>
+          <a:xfrm>
+            <a:off x="5943600" y="1938528"/>
+            <a:ext cx="128016" cy="0"/>
+          </a:xfrm>
+          <a:prstGeom prst="line">
+            <a:avLst/>
+          </a:prstGeom>
+          <a:noFill/>
+          <a:ln w="25400">
+            <a:solidFill>
+              <a:srgbClr val="555555"/>
+            </a:solidFill>
+            <a:prstDash val="solid"/>
+            <a:tailEnd type="triangle"/>
+          </a:ln>
+        </p:spPr>
+        <p:txBody>
+          <a:bodyPr/>
+          <a:lstStyle/>
+          <a:p>
+            <a:endParaRPr sz="1050"/>
+          </a:p>
+        </p:txBody>
+      </p:sp>
+      <p:sp>
+        <p:nvSpPr>
+          <p:cNvPr id="110" name="Train 5"/>
+          <p:cNvSpPr/>
+          <p:nvPr/>
+        </p:nvSpPr>
+        <p:spPr>
+          <a:xfrm>
+            <a:off x="6099048" y="1481328"/>
+            <a:ext cx="1216152" cy="914400"/>
+          </a:xfrm>
+          <a:prstGeom prst="roundRect">
+            <a:avLst/>
+          </a:prstGeom>
+          <a:solidFill>
+            <a:srgbClr val="FFFFFF"/>
+          </a:solidFill>
+          <a:ln w="9525">
+            <a:solidFill>
+              <a:srgbClr val="CDD2D7"/>
+            </a:solidFill>
+          </a:ln>
+        </p:spPr>
+        <p:style>
+          <a:lnRef idx="1">
+            <a:schemeClr val="accent1"/>
+          </a:lnRef>
+          <a:fillRef idx="3">
+            <a:schemeClr val="accent1"/>
+          </a:fillRef>
+          <a:effectRef idx="2">
+            <a:schemeClr val="accent1"/>
+          </a:effectRef>
+          <a:fontRef idx="minor">
+            <a:schemeClr val="lt1"/>
+          </a:fontRef>
+        </p:style>
+        <p:txBody>
+          <a:bodyPr wrap="square" lIns="54864" tIns="36576" rIns="54864" bIns="36576" rtlCol="0" anchor="ctr"/>
+          <a:lstStyle/>
+          <a:p>
+            <a:pPr algn="ctr"/>
+            <a:r>
+              <a:rPr sz="1000" b="1">
+                <a:solidFill>
+                  <a:srgbClr val="121212"/>
+                </a:solidFill>
+                <a:latin typeface="Arial"/>
+              </a:rPr>
+              <a:t>Head (1 per run)</a:t>
+            </a:r>
+          </a:p>
+          <a:p>
+            <a:pPr algn="ctr"/>
+            <a:r>
+              <a:rPr sz="800" b="0">
+                <a:solidFill>
+                  <a:srgbClr val="2B2B2B"/>
+                </a:solidFill>
+                <a:latin typeface="Arial"/>
+              </a:rPr>
+              <a:t>0 vs 1-4, early vs late, 3-class or 5-grade</a:t>
+            </a:r>
+          </a:p>
+        </p:txBody>
+      </p:sp>
+      <p:sp>
+        <p:nvSpPr>
+          <p:cNvPr id="111" name="Arrow 5"/>
+          <p:cNvSpPr/>
+          <p:nvPr/>
+        </p:nvSpPr>
+        <p:spPr>
+          <a:xfrm>
+            <a:off x="7342631" y="1938528"/>
+            <a:ext cx="128016" cy="0"/>
+          </a:xfrm>
+          <a:prstGeom prst="line">
+            <a:avLst/>
+          </a:prstGeom>
+          <a:noFill/>
+          <a:ln w="25400">
+            <a:solidFill>
+              <a:srgbClr val="555555"/>
+            </a:solidFill>
+            <a:prstDash val="solid"/>
+            <a:tailEnd type="triangle"/>
+          </a:ln>
+        </p:spPr>
+        <p:txBody>
+          <a:bodyPr/>
+          <a:lstStyle/>
+          <a:p>
+            <a:endParaRPr sz="1050"/>
+          </a:p>
+        </p:txBody>
+      </p:sp>
+      <p:sp>
+        <p:nvSpPr>
+          <p:cNvPr id="112" name="Train 6"/>
+          <p:cNvSpPr/>
+          <p:nvPr/>
+        </p:nvSpPr>
+        <p:spPr>
+          <a:xfrm>
+            <a:off x="7498080" y="1481328"/>
+            <a:ext cx="1216152" cy="914400"/>
+          </a:xfrm>
+          <a:prstGeom prst="roundRect">
+            <a:avLst/>
+          </a:prstGeom>
+          <a:solidFill>
+            <a:srgbClr val="FFFFFF"/>
+          </a:solidFill>
+          <a:ln w="9525">
+            <a:solidFill>
+              <a:srgbClr val="CDD2D7"/>
+            </a:solidFill>
+          </a:ln>
+        </p:spPr>
+        <p:style>
+          <a:lnRef idx="1">
+            <a:schemeClr val="accent1"/>
+          </a:lnRef>
+          <a:fillRef idx="3">
+            <a:schemeClr val="accent1"/>
+          </a:fillRef>
+          <a:effectRef idx="2">
+            <a:schemeClr val="accent1"/>
+          </a:effectRef>
+          <a:fontRef idx="minor">
+            <a:schemeClr val="lt1"/>
+          </a:fontRef>
+        </p:style>
+        <p:txBody>
+          <a:bodyPr wrap="square" lIns="54864" tIns="36576" rIns="54864" bIns="36576" rtlCol="0" anchor="ctr"/>
+          <a:lstStyle/>
+          <a:p>
+            <a:pPr algn="ctr"/>
+            <a:r>
+              <a:rPr sz="1000" b="1">
+                <a:solidFill>
+                  <a:srgbClr val="121212"/>
+                </a:solidFill>
+                <a:latin typeface="Arial"/>
+              </a:rPr>
+              <a:t>Loss</a:t>
+            </a:r>
+          </a:p>
+          <a:p>
+            <a:pPr algn="ctr"/>
+            <a:r>
+              <a:rPr sz="800" b="0">
+                <a:solidFill>
+                  <a:srgbClr val="2B2B2B"/>
+                </a:solidFill>
+                <a:latin typeface="Arial"/>
+              </a:rPr>
+              <a:t>Cross-entropy, class-balanced CE, or focal (gamma 1-3)</a:t>
+            </a:r>
+          </a:p>
+        </p:txBody>
+      </p:sp>
+      <p:sp>
+        <p:nvSpPr>
+          <p:cNvPr id="113" name="Arrow down"/>
+          <p:cNvSpPr/>
+          <p:nvPr/>
+        </p:nvSpPr>
+        <p:spPr>
+          <a:xfrm>
+            <a:off x="8106156" y="2423160"/>
+            <a:ext cx="0" cy="502920"/>
+          </a:xfrm>
+          <a:prstGeom prst="line">
+            <a:avLst/>
+          </a:prstGeom>
+          <a:noFill/>
+          <a:ln w="25400">
+            <a:solidFill>
+              <a:srgbClr val="555555"/>
+            </a:solidFill>
+            <a:prstDash val="solid"/>
+            <a:tailEnd type="triangle"/>
+          </a:ln>
+        </p:spPr>
+        <p:txBody>
+          <a:bodyPr/>
+          <a:lstStyle/>
+          <a:p>
+            <a:endParaRPr sz="1050"/>
+          </a:p>
+        </p:txBody>
+      </p:sp>
+      <p:sp>
+        <p:nvSpPr>
+          <p:cNvPr id="114" name="Label validate"/>
+          <p:cNvSpPr txBox="1"/>
+          <p:nvPr/>
+        </p:nvSpPr>
+        <p:spPr>
+          <a:xfrm>
+            <a:off x="502920" y="2651760"/>
+            <a:ext cx="5486400" cy="201168"/>
+          </a:xfrm>
+          <a:prstGeom prst="rect">
+            <a:avLst/>
+          </a:prstGeom>
+          <a:noFill/>
+        </p:spPr>
+        <p:txBody>
+          <a:bodyPr wrap="square" lIns="27432" tIns="18288" rIns="27432" bIns="18288" anchor="t">
+            <a:spAutoFit/>
+          </a:bodyPr>
+          <a:lstStyle/>
+          <a:p>
+            <a:pPr algn="l"/>
+            <a:r>
+              <a:rPr sz="950" b="1">
+                <a:solidFill>
+                  <a:srgbClr val="1E7A5A"/>
+                </a:solidFill>
+                <a:latin typeface="Arial"/>
+              </a:rPr>
+              <a:t>VALIDATE AND FREEZE, THEN TEST</a:t>
+            </a:r>
+          </a:p>
+        </p:txBody>
+      </p:sp>
+      <p:sp>
+        <p:nvSpPr>
+          <p:cNvPr id="115" name="Eval 1"/>
+          <p:cNvSpPr/>
+          <p:nvPr/>
+        </p:nvSpPr>
+        <p:spPr>
+          <a:xfrm>
+            <a:off x="7251192" y="3017520"/>
+            <a:ext cx="1463040" cy="914400"/>
+          </a:xfrm>
+          <a:prstGeom prst="roundRect">
+            <a:avLst/>
+          </a:prstGeom>
+          <a:solidFill>
+            <a:srgbClr val="BCCFE4"/>
+          </a:solidFill>
+          <a:ln w="9525">
+            <a:solidFill>
+              <a:srgbClr val="BCCFE4"/>
+            </a:solidFill>
+          </a:ln>
+        </p:spPr>
+        <p:style>
+          <a:lnRef idx="1">
+            <a:schemeClr val="accent1"/>
+          </a:lnRef>
+          <a:fillRef idx="3">
+            <a:schemeClr val="accent1"/>
+          </a:fillRef>
+          <a:effectRef idx="2">
+            <a:schemeClr val="accent1"/>
+          </a:effectRef>
+          <a:fontRef idx="minor">
+            <a:schemeClr val="lt1"/>
+          </a:fontRef>
+        </p:style>
+        <p:txBody>
+          <a:bodyPr wrap="square" lIns="54864" tIns="36576" rIns="54864" bIns="36576" rtlCol="0" anchor="ctr"/>
+          <a:lstStyle/>
+          <a:p>
+            <a:pPr algn="ctr"/>
+            <a:r>
+              <a:rPr sz="1000" b="1">
+                <a:solidFill>
+                  <a:srgbClr val="121212"/>
+                </a:solidFill>
+                <a:latin typeface="Arial"/>
+              </a:rPr>
+              <a:t>Best epoch</a:t>
+            </a:r>
+          </a:p>
+          <a:p>
+            <a:pPr algn="ctr"/>
+            <a:r>
+              <a:rPr sz="800" b="0">
+                <a:solidFill>
+                  <a:srgbClr val="2B2B2B"/>
+                </a:solidFill>
+                <a:latin typeface="Arial"/>
+              </a:rPr>
+              <a:t>Chosen on validation score only</a:t>
+            </a:r>
+          </a:p>
+        </p:txBody>
+      </p:sp>
+      <p:sp>
+        <p:nvSpPr>
+          <p:cNvPr id="116" name="Arrow back 1"/>
+          <p:cNvSpPr/>
+          <p:nvPr/>
+        </p:nvSpPr>
+        <p:spPr>
+          <a:xfrm flipH="1">
+            <a:off x="7054596" y="3474720"/>
+            <a:ext cx="169164" cy="0"/>
+          </a:xfrm>
+          <a:prstGeom prst="line">
+            <a:avLst/>
+          </a:prstGeom>
+          <a:noFill/>
+          <a:ln w="25400">
+            <a:solidFill>
+              <a:srgbClr val="555555"/>
+            </a:solidFill>
+            <a:prstDash val="solid"/>
+            <a:tailEnd type="triangle"/>
+          </a:ln>
+        </p:spPr>
+        <p:txBody>
+          <a:bodyPr/>
+          <a:lstStyle/>
+          <a:p>
+            <a:endParaRPr sz="1050"/>
+          </a:p>
+        </p:txBody>
+      </p:sp>
+      <p:sp>
+        <p:nvSpPr>
+          <p:cNvPr id="117" name="Eval 2"/>
+          <p:cNvSpPr/>
+          <p:nvPr/>
+        </p:nvSpPr>
+        <p:spPr>
+          <a:xfrm>
+            <a:off x="5564124" y="3017520"/>
+            <a:ext cx="1463040" cy="914400"/>
+          </a:xfrm>
+          <a:prstGeom prst="roundRect">
+            <a:avLst/>
+          </a:prstGeom>
+          <a:solidFill>
+            <a:srgbClr val="FFFFFF"/>
+          </a:solidFill>
+          <a:ln w="9525">
+            <a:solidFill>
+              <a:srgbClr val="CDD2D7"/>
+            </a:solidFill>
+          </a:ln>
+        </p:spPr>
+        <p:style>
+          <a:lnRef idx="1">
+            <a:schemeClr val="accent1"/>
+          </a:lnRef>
+          <a:fillRef idx="3">
+            <a:schemeClr val="accent1"/>
+          </a:fillRef>
+          <a:effectRef idx="2">
+            <a:schemeClr val="accent1"/>
+          </a:effectRef>
+          <a:fontRef idx="minor">
+            <a:schemeClr val="lt1"/>
+          </a:fontRef>
+        </p:style>
+        <p:txBody>
+          <a:bodyPr wrap="square" lIns="54864" tIns="36576" rIns="54864" bIns="36576" rtlCol="0" anchor="ctr"/>
+          <a:lstStyle/>
+          <a:p>
+            <a:pPr algn="ctr"/>
+            <a:r>
+              <a:rPr sz="1000" b="1">
+                <a:solidFill>
+                  <a:srgbClr val="121212"/>
+                </a:solidFill>
+                <a:latin typeface="Arial"/>
+              </a:rPr>
+              <a:t>Temperature scaling</a:t>
+            </a:r>
+          </a:p>
+          <a:p>
+            <a:pPr algn="ctr"/>
+            <a:r>
+              <a:rPr sz="800" b="0">
+                <a:solidFill>
+                  <a:srgbClr val="2B2B2B"/>
+                </a:solidFill>
+                <a:latin typeface="Arial"/>
+              </a:rPr>
+              <a:t>One number T, fitted on validation</a:t>
+            </a:r>
+          </a:p>
+        </p:txBody>
+      </p:sp>
+      <p:sp>
+        <p:nvSpPr>
+          <p:cNvPr id="118" name="Arrow back 2"/>
+          <p:cNvSpPr/>
+          <p:nvPr/>
+        </p:nvSpPr>
+        <p:spPr>
+          <a:xfrm flipH="1">
+            <a:off x="5367528" y="3474720"/>
+            <a:ext cx="169164" cy="0"/>
+          </a:xfrm>
+          <a:prstGeom prst="line">
+            <a:avLst/>
+          </a:prstGeom>
+          <a:noFill/>
+          <a:ln w="25400">
+            <a:solidFill>
+              <a:srgbClr val="555555"/>
+            </a:solidFill>
+            <a:prstDash val="solid"/>
+            <a:tailEnd type="triangle"/>
+          </a:ln>
+        </p:spPr>
+        <p:txBody>
+          <a:bodyPr/>
+          <a:lstStyle/>
+          <a:p>
+            <a:endParaRPr sz="1050"/>
+          </a:p>
+        </p:txBody>
+      </p:sp>
+      <p:sp>
+        <p:nvSpPr>
+          <p:cNvPr id="119" name="Eval 3"/>
+          <p:cNvSpPr/>
+          <p:nvPr/>
+        </p:nvSpPr>
+        <p:spPr>
+          <a:xfrm>
+            <a:off x="3877056" y="3017520"/>
+            <a:ext cx="1463040" cy="914400"/>
+          </a:xfrm>
+          <a:prstGeom prst="roundRect">
+            <a:avLst/>
+          </a:prstGeom>
+          <a:solidFill>
+            <a:srgbClr val="FFFFFF"/>
+          </a:solidFill>
+          <a:ln w="9525">
+            <a:solidFill>
+              <a:srgbClr val="CDD2D7"/>
+            </a:solidFill>
+          </a:ln>
+        </p:spPr>
+        <p:style>
+          <a:lnRef idx="1">
+            <a:schemeClr val="accent1"/>
+          </a:lnRef>
+          <a:fillRef idx="3">
+            <a:schemeClr val="accent1"/>
+          </a:fillRef>
+          <a:effectRef idx="2">
+            <a:schemeClr val="accent1"/>
+          </a:effectRef>
+          <a:fontRef idx="minor">
+            <a:schemeClr val="lt1"/>
+          </a:fontRef>
+        </p:style>
+        <p:txBody>
+          <a:bodyPr wrap="square" lIns="54864" tIns="36576" rIns="54864" bIns="36576" rtlCol="0" anchor="ctr"/>
+          <a:lstStyle/>
+          <a:p>
+            <a:pPr algn="ctr"/>
+            <a:r>
+              <a:rPr sz="1000" b="1">
+                <a:solidFill>
+                  <a:srgbClr val="121212"/>
+                </a:solidFill>
+                <a:latin typeface="Arial"/>
+              </a:rPr>
+              <a:t>Prior-shift correction</a:t>
+            </a:r>
+          </a:p>
+          <a:p>
+            <a:pPr algn="ctr"/>
+            <a:r>
+              <a:rPr sz="800" b="0">
+                <a:solidFill>
+                  <a:srgbClr val="2B2B2B"/>
+                </a:solidFill>
+                <a:latin typeface="Arial"/>
+              </a:rPr>
+              <a:t>Training class mix back to natural prevalence</a:t>
+            </a:r>
+          </a:p>
+        </p:txBody>
+      </p:sp>
+      <p:sp>
+        <p:nvSpPr>
+          <p:cNvPr id="120" name="Arrow back 3"/>
+          <p:cNvSpPr/>
+          <p:nvPr/>
+        </p:nvSpPr>
+        <p:spPr>
+          <a:xfrm flipH="1">
+            <a:off x="3680460" y="3474720"/>
+            <a:ext cx="169164" cy="0"/>
+          </a:xfrm>
+          <a:prstGeom prst="line">
+            <a:avLst/>
+          </a:prstGeom>
+          <a:noFill/>
+          <a:ln w="25400">
+            <a:solidFill>
+              <a:srgbClr val="555555"/>
+            </a:solidFill>
+            <a:prstDash val="solid"/>
+            <a:tailEnd type="triangle"/>
+          </a:ln>
+        </p:spPr>
+        <p:txBody>
+          <a:bodyPr/>
+          <a:lstStyle/>
+          <a:p>
+            <a:endParaRPr sz="1050"/>
+          </a:p>
+        </p:txBody>
+      </p:sp>
+      <p:sp>
+        <p:nvSpPr>
+          <p:cNvPr id="121" name="Eval 4"/>
+          <p:cNvSpPr/>
+          <p:nvPr/>
+        </p:nvSpPr>
+        <p:spPr>
+          <a:xfrm>
+            <a:off x="2189988" y="3017520"/>
+            <a:ext cx="1463040" cy="914400"/>
+          </a:xfrm>
+          <a:prstGeom prst="roundRect">
+            <a:avLst/>
+          </a:prstGeom>
+          <a:solidFill>
+            <a:srgbClr val="FFFFFF"/>
+          </a:solidFill>
+          <a:ln w="9525">
+            <a:solidFill>
+              <a:srgbClr val="CDD2D7"/>
+            </a:solidFill>
+          </a:ln>
+        </p:spPr>
+        <p:style>
+          <a:lnRef idx="1">
+            <a:schemeClr val="accent1"/>
+          </a:lnRef>
+          <a:fillRef idx="3">
+            <a:schemeClr val="accent1"/>
+          </a:fillRef>
+          <a:effectRef idx="2">
+            <a:schemeClr val="accent1"/>
+          </a:effectRef>
+          <a:fontRef idx="minor">
+            <a:schemeClr val="lt1"/>
+          </a:fontRef>
+        </p:style>
+        <p:txBody>
+          <a:bodyPr wrap="square" lIns="54864" tIns="36576" rIns="54864" bIns="36576" rtlCol="0" anchor="ctr"/>
+          <a:lstStyle/>
+          <a:p>
+            <a:pPr algn="ctr"/>
+            <a:r>
+              <a:rPr sz="1000" b="1">
+                <a:solidFill>
+                  <a:srgbClr val="121212"/>
+                </a:solidFill>
+                <a:latin typeface="Arial"/>
+              </a:rPr>
+              <a:t>Frozen threshold</a:t>
+            </a:r>
+          </a:p>
+          <a:p>
+            <a:pPr algn="ctr"/>
+            <a:r>
+              <a:rPr sz="800" b="0">
+                <a:solidFill>
+                  <a:srgbClr val="2B2B2B"/>
+                </a:solidFill>
+                <a:latin typeface="Arial"/>
+              </a:rPr>
+              <a:t>Set at the declared specificity (0.90) on validation</a:t>
+            </a:r>
+          </a:p>
+        </p:txBody>
+      </p:sp>
+      <p:sp>
+        <p:nvSpPr>
+          <p:cNvPr id="122" name="Arrow back 4"/>
+          <p:cNvSpPr/>
+          <p:nvPr/>
+        </p:nvSpPr>
+        <p:spPr>
+          <a:xfrm flipH="1">
+            <a:off x="1993392" y="3474720"/>
+            <a:ext cx="169164" cy="0"/>
+          </a:xfrm>
+          <a:prstGeom prst="line">
+            <a:avLst/>
+          </a:prstGeom>
+          <a:noFill/>
+          <a:ln w="25400">
+            <a:solidFill>
+              <a:srgbClr val="555555"/>
+            </a:solidFill>
+            <a:prstDash val="solid"/>
+            <a:tailEnd type="triangle"/>
+          </a:ln>
+        </p:spPr>
+        <p:txBody>
+          <a:bodyPr/>
+          <a:lstStyle/>
+          <a:p>
+            <a:endParaRPr sz="1050"/>
+          </a:p>
+        </p:txBody>
+      </p:sp>
+      <p:sp>
+        <p:nvSpPr>
+          <p:cNvPr id="123" name="Eval 5"/>
+          <p:cNvSpPr/>
+          <p:nvPr/>
+        </p:nvSpPr>
+        <p:spPr>
+          <a:xfrm>
+            <a:off x="502920" y="3017520"/>
+            <a:ext cx="1463040" cy="914400"/>
+          </a:xfrm>
+          <a:prstGeom prst="roundRect">
+            <a:avLst/>
+          </a:prstGeom>
+          <a:solidFill>
+            <a:srgbClr val="FFF0B3"/>
+          </a:solidFill>
+          <a:ln w="9525">
+            <a:solidFill>
+              <a:srgbClr val="E0B400"/>
+            </a:solidFill>
+          </a:ln>
+        </p:spPr>
+        <p:style>
+          <a:lnRef idx="1">
+            <a:schemeClr val="accent1"/>
+          </a:lnRef>
+          <a:fillRef idx="3">
+            <a:schemeClr val="accent1"/>
+          </a:fillRef>
+          <a:effectRef idx="2">
+            <a:schemeClr val="accent1"/>
+          </a:effectRef>
+          <a:fontRef idx="minor">
+            <a:schemeClr val="lt1"/>
+          </a:fontRef>
+        </p:style>
+        <p:txBody>
+          <a:bodyPr wrap="square" lIns="54864" tIns="36576" rIns="54864" bIns="36576" rtlCol="0" anchor="ctr"/>
+          <a:lstStyle/>
+          <a:p>
+            <a:pPr algn="ctr"/>
+            <a:r>
+              <a:rPr sz="1000" b="1">
+                <a:solidFill>
+                  <a:srgbClr val="121212"/>
+                </a:solidFill>
+                <a:latin typeface="Arial"/>
+              </a:rPr>
+              <a:t>Outputs</a:t>
+            </a:r>
+          </a:p>
+          <a:p>
+            <a:pPr algn="ctr"/>
+            <a:r>
+              <a:rPr sz="800" b="0">
+                <a:solidFill>
+                  <a:srgbClr val="2B2B2B"/>
+                </a:solidFill>
+                <a:latin typeface="Arial"/>
+              </a:rPr>
+              <a:t>Calibrated probability, early-DR flag, per-source metrics with 95% CI</a:t>
+            </a:r>
+          </a:p>
+        </p:txBody>
+      </p:sp>
+      <p:sp>
+        <p:nvSpPr>
+          <p:cNvPr id="124" name="Banner"/>
+          <p:cNvSpPr/>
+          <p:nvPr/>
+        </p:nvSpPr>
+        <p:spPr>
+          <a:xfrm>
+            <a:off x="502920" y="4133087"/>
+            <a:ext cx="8211312" cy="384048"/>
+          </a:xfrm>
+          <a:prstGeom prst="roundRect">
+            <a:avLst/>
+          </a:prstGeom>
+          <a:solidFill>
+            <a:srgbClr val="F2F5F8"/>
+          </a:solidFill>
+          <a:ln w="9525">
+            <a:solidFill>
+              <a:srgbClr val="CDD2D7"/>
+            </a:solidFill>
+          </a:ln>
+        </p:spPr>
+        <p:style>
+          <a:lnRef idx="1">
+            <a:schemeClr val="accent1"/>
+          </a:lnRef>
+          <a:fillRef idx="3">
+            <a:schemeClr val="accent1"/>
+          </a:fillRef>
+          <a:effectRef idx="2">
+            <a:schemeClr val="accent1"/>
+          </a:effectRef>
+          <a:fontRef idx="minor">
+            <a:schemeClr val="lt1"/>
+          </a:fontRef>
+        </p:style>
+        <p:txBody>
+          <a:bodyPr wrap="square" lIns="54864" tIns="36576" rIns="54864" bIns="36576" rtlCol="0" anchor="ctr"/>
+          <a:lstStyle/>
+          <a:p>
+            <a:pPr algn="ctr"/>
+            <a:r>
+              <a:rPr sz="980" b="1">
+                <a:solidFill>
+                  <a:srgbClr val="121212"/>
+                </a:solidFill>
+                <a:latin typeface="Arial"/>
+              </a:rPr>
+              <a:t>Test sets opened once: DDR + held-out EyePACS, then APTOS last. Grad-CAM with a randomised-weights check.</a:t>
+            </a:r>
+          </a:p>
+        </p:txBody>
+      </p:sp>
+    </p:spTree>
+  </p:cSld>
+  <p:clrMapOvr>
+    <a:masterClrMapping/>
+  </p:clrMapOvr>
+</p:sld>
+</file>
+
 <file path=ppt/slides/slide2.xml><?xml version="1.0" encoding="utf-8"?>
 <p:sld xmlns:a="http://schemas.openxmlformats.org/drawingml/2006/main" xmlns:r="http://schemas.openxmlformats.org/officeDocument/2006/relationships" xmlns:p="http://schemas.openxmlformats.org/presentationml/2006/main">
   <p:cSld>
@@ -25369,7 +26658,7 @@
           <a:p>
             <a:r>
               <a:rPr lang="en-US" sz="1100" dirty="0"/>
-              <a:t>6</a:t>
+              <a:t>7</a:t>
             </a:r>
           </a:p>
         </p:txBody>
@@ -26263,7 +27552,7 @@
           <a:p>
             <a:r>
               <a:rPr lang="en-US" sz="1100" dirty="0"/>
-              <a:t>7</a:t>
+              <a:t>8</a:t>
             </a:r>
           </a:p>
         </p:txBody>
@@ -26566,7 +27855,7 @@
           <a:p>
             <a:r>
               <a:rPr lang="en-US" sz="1100" dirty="0"/>
-              <a:t>8</a:t>
+              <a:t>9</a:t>
             </a:r>
           </a:p>
         </p:txBody>

</xml_diff>